<commit_message>
Update progress deck: per-commit/feature token usage breakdown
Replaces the single time-bucketed usage chart with a horizontal bar
chart showing tokens, cost, and call count per commit/feature, plus
a rerouting/live-departures/alternatives showcase slide.
</commit_message>
<xml_diff>
--- a/Reroute_progress.pptx
+++ b/Reroute_progress.pptx
@@ -21,6 +21,7 @@
     <p:sldId id="269" r:id="rId20"/>
     <p:sldId id="270" r:id="rId21"/>
     <p:sldId id="271" r:id="rId22"/>
+    <p:sldId id="272" r:id="rId23"/>
   </p:sldIdLst>
   <p:sldSz cx="12191695" cy="6858000" type="screen4x3"/>
   <p:notesSz cx="6858000" cy="9144000"/>
@@ -3880,8 +3881,8 @@
         </p:nvSpPr>
         <p:spPr>
           <a:xfrm>
-            <a:off x="640080" y="411480"/>
-            <a:ext cx="9144000" cy="548640"/>
+            <a:off x="640080" y="365760"/>
+            <a:ext cx="10881360" cy="548640"/>
           </a:xfrm>
           <a:prstGeom prst="rect">
             <a:avLst/>
@@ -3902,7 +3903,7 @@
                 </a:solidFill>
                 <a:latin typeface="Helvetica Neue"/>
               </a:rPr>
-              <a:t>Token usage across the build</a:t>
+              <a:t>Token usage: which feature cost what</a:t>
             </a:r>
           </a:p>
         </p:txBody>
@@ -3915,8 +3916,8 @@
         </p:nvSpPr>
         <p:spPr>
           <a:xfrm>
-            <a:off x="640080" y="914400"/>
-            <a:ext cx="10515600" cy="457200"/>
+            <a:off x="640080" y="868680"/>
+            <a:ext cx="10881360" cy="502920"/>
           </a:xfrm>
           <a:prstGeom prst="rect">
             <a:avLst/>
@@ -3931,20 +3932,20 @@
           <a:p>
             <a:pPr algn="l"/>
             <a:r>
-              <a:rPr sz="1400" b="0">
+              <a:rPr sz="1350" b="0">
                 <a:solidFill>
                   <a:srgbClr val="52514E"/>
                 </a:solidFill>
                 <a:latin typeface="Helvetica Neue"/>
               </a:rPr>
-              <a:t>Pulled from local Claude Code session transcripts for today (all assistant turns, deduped by message id).</a:t>
+              <a:t>Every assistant turn in today's Claude Code sessions, bucketed by the git commit it produced — from the same local session transcripts.</a:t>
             </a:r>
           </a:p>
         </p:txBody>
       </p:sp>
       <p:pic>
         <p:nvPicPr>
-          <p:cNvPr id="5" name="Picture 4" descr="usage_chart.png"/>
+          <p:cNvPr id="5" name="Picture 4" descr="usage_by_commit_chart.png"/>
           <p:cNvPicPr>
             <a:picLocks noChangeAspect="1"/>
           </p:cNvPicPr>
@@ -3958,470 +3959,14 @@
         </p:blipFill>
         <p:spPr>
           <a:xfrm>
-            <a:off x="548640" y="2000873"/>
-            <a:ext cx="7680960" cy="3770653"/>
+            <a:off x="1075891" y="1463040"/>
+            <a:ext cx="10009738" cy="5120640"/>
           </a:xfrm>
           <a:prstGeom prst="rect">
             <a:avLst/>
           </a:prstGeom>
         </p:spPr>
       </p:pic>
-      <p:sp>
-        <p:nvSpPr>
-          <p:cNvPr id="6" name="Rectangle 5"/>
-          <p:cNvSpPr/>
-          <p:nvPr/>
-        </p:nvSpPr>
-        <p:spPr>
-          <a:xfrm>
-            <a:off x="8503920" y="1554480"/>
-            <a:ext cx="3017520" cy="914400"/>
-          </a:xfrm>
-          <a:prstGeom prst="rect">
-            <a:avLst/>
-          </a:prstGeom>
-          <a:solidFill>
-            <a:srgbClr val="FFFFFF"/>
-          </a:solidFill>
-          <a:ln>
-            <a:noFill/>
-          </a:ln>
-          <a:effectLst/>
-        </p:spPr>
-        <p:style>
-          <a:lnRef idx="1">
-            <a:schemeClr val="accent1"/>
-          </a:lnRef>
-          <a:fillRef idx="3">
-            <a:schemeClr val="accent1"/>
-          </a:fillRef>
-          <a:effectRef idx="2">
-            <a:schemeClr val="accent1"/>
-          </a:effectRef>
-          <a:fontRef idx="minor">
-            <a:schemeClr val="lt1"/>
-          </a:fontRef>
-        </p:style>
-        <p:txBody>
-          <a:bodyPr rtlCol="0" anchor="ctr"/>
-          <a:lstStyle/>
-          <a:p>
-            <a:pPr algn="ctr"/>
-          </a:p>
-        </p:txBody>
-      </p:sp>
-      <p:sp>
-        <p:nvSpPr>
-          <p:cNvPr id="7" name="TextBox 6"/>
-          <p:cNvSpPr txBox="1"/>
-          <p:nvPr/>
-        </p:nvSpPr>
-        <p:spPr>
-          <a:xfrm>
-            <a:off x="8686800" y="1627632"/>
-            <a:ext cx="2743200" cy="457200"/>
-          </a:xfrm>
-          <a:prstGeom prst="rect">
-            <a:avLst/>
-          </a:prstGeom>
-          <a:noFill/>
-        </p:spPr>
-        <p:txBody>
-          <a:bodyPr wrap="square">
-            <a:spAutoFit/>
-          </a:bodyPr>
-          <a:lstStyle/>
-          <a:p>
-            <a:pPr algn="l"/>
-            <a:r>
-              <a:rPr sz="2600" b="1">
-                <a:solidFill>
-                  <a:srgbClr val="0B3D91"/>
-                </a:solidFill>
-                <a:latin typeface="Helvetica Neue"/>
-              </a:rPr>
-              <a:t>824</a:t>
-            </a:r>
-          </a:p>
-        </p:txBody>
-      </p:sp>
-      <p:sp>
-        <p:nvSpPr>
-          <p:cNvPr id="8" name="TextBox 7"/>
-          <p:cNvSpPr txBox="1"/>
-          <p:nvPr/>
-        </p:nvSpPr>
-        <p:spPr>
-          <a:xfrm>
-            <a:off x="8686800" y="2084832"/>
-            <a:ext cx="2743200" cy="320040"/>
-          </a:xfrm>
-          <a:prstGeom prst="rect">
-            <a:avLst/>
-          </a:prstGeom>
-          <a:noFill/>
-        </p:spPr>
-        <p:txBody>
-          <a:bodyPr wrap="square">
-            <a:spAutoFit/>
-          </a:bodyPr>
-          <a:lstStyle/>
-          <a:p>
-            <a:pPr algn="l"/>
-            <a:r>
-              <a:rPr sz="1200" b="0">
-                <a:solidFill>
-                  <a:srgbClr val="52514E"/>
-                </a:solidFill>
-                <a:latin typeface="Helvetica Neue"/>
-              </a:rPr>
-              <a:t>model turns</a:t>
-            </a:r>
-          </a:p>
-        </p:txBody>
-      </p:sp>
-      <p:sp>
-        <p:nvSpPr>
-          <p:cNvPr id="9" name="Rectangle 8"/>
-          <p:cNvSpPr/>
-          <p:nvPr/>
-        </p:nvSpPr>
-        <p:spPr>
-          <a:xfrm>
-            <a:off x="8503920" y="2697480"/>
-            <a:ext cx="3017520" cy="914400"/>
-          </a:xfrm>
-          <a:prstGeom prst="rect">
-            <a:avLst/>
-          </a:prstGeom>
-          <a:solidFill>
-            <a:srgbClr val="FFFFFF"/>
-          </a:solidFill>
-          <a:ln>
-            <a:noFill/>
-          </a:ln>
-          <a:effectLst/>
-        </p:spPr>
-        <p:style>
-          <a:lnRef idx="1">
-            <a:schemeClr val="accent1"/>
-          </a:lnRef>
-          <a:fillRef idx="3">
-            <a:schemeClr val="accent1"/>
-          </a:fillRef>
-          <a:effectRef idx="2">
-            <a:schemeClr val="accent1"/>
-          </a:effectRef>
-          <a:fontRef idx="minor">
-            <a:schemeClr val="lt1"/>
-          </a:fontRef>
-        </p:style>
-        <p:txBody>
-          <a:bodyPr rtlCol="0" anchor="ctr"/>
-          <a:lstStyle/>
-          <a:p>
-            <a:pPr algn="ctr"/>
-          </a:p>
-        </p:txBody>
-      </p:sp>
-      <p:sp>
-        <p:nvSpPr>
-          <p:cNvPr id="10" name="TextBox 9"/>
-          <p:cNvSpPr txBox="1"/>
-          <p:nvPr/>
-        </p:nvSpPr>
-        <p:spPr>
-          <a:xfrm>
-            <a:off x="8686800" y="2770632"/>
-            <a:ext cx="2743200" cy="457200"/>
-          </a:xfrm>
-          <a:prstGeom prst="rect">
-            <a:avLst/>
-          </a:prstGeom>
-          <a:noFill/>
-        </p:spPr>
-        <p:txBody>
-          <a:bodyPr wrap="square">
-            <a:spAutoFit/>
-          </a:bodyPr>
-          <a:lstStyle/>
-          <a:p>
-            <a:pPr algn="l"/>
-            <a:r>
-              <a:rPr sz="2600" b="1">
-                <a:solidFill>
-                  <a:srgbClr val="0B3D91"/>
-                </a:solidFill>
-                <a:latin typeface="Helvetica Neue"/>
-              </a:rPr>
-              <a:t>501K</a:t>
-            </a:r>
-          </a:p>
-        </p:txBody>
-      </p:sp>
-      <p:sp>
-        <p:nvSpPr>
-          <p:cNvPr id="11" name="TextBox 10"/>
-          <p:cNvSpPr txBox="1"/>
-          <p:nvPr/>
-        </p:nvSpPr>
-        <p:spPr>
-          <a:xfrm>
-            <a:off x="8686800" y="3227832"/>
-            <a:ext cx="2743200" cy="320040"/>
-          </a:xfrm>
-          <a:prstGeom prst="rect">
-            <a:avLst/>
-          </a:prstGeom>
-          <a:noFill/>
-        </p:spPr>
-        <p:txBody>
-          <a:bodyPr wrap="square">
-            <a:spAutoFit/>
-          </a:bodyPr>
-          <a:lstStyle/>
-          <a:p>
-            <a:pPr algn="l"/>
-            <a:r>
-              <a:rPr sz="1200" b="0">
-                <a:solidFill>
-                  <a:srgbClr val="52514E"/>
-                </a:solidFill>
-                <a:latin typeface="Helvetica Neue"/>
-              </a:rPr>
-              <a:t>output tokens</a:t>
-            </a:r>
-          </a:p>
-        </p:txBody>
-      </p:sp>
-      <p:sp>
-        <p:nvSpPr>
-          <p:cNvPr id="12" name="Rectangle 11"/>
-          <p:cNvSpPr/>
-          <p:nvPr/>
-        </p:nvSpPr>
-        <p:spPr>
-          <a:xfrm>
-            <a:off x="8503920" y="3840480"/>
-            <a:ext cx="3017520" cy="914400"/>
-          </a:xfrm>
-          <a:prstGeom prst="rect">
-            <a:avLst/>
-          </a:prstGeom>
-          <a:solidFill>
-            <a:srgbClr val="FFFFFF"/>
-          </a:solidFill>
-          <a:ln>
-            <a:noFill/>
-          </a:ln>
-          <a:effectLst/>
-        </p:spPr>
-        <p:style>
-          <a:lnRef idx="1">
-            <a:schemeClr val="accent1"/>
-          </a:lnRef>
-          <a:fillRef idx="3">
-            <a:schemeClr val="accent1"/>
-          </a:fillRef>
-          <a:effectRef idx="2">
-            <a:schemeClr val="accent1"/>
-          </a:effectRef>
-          <a:fontRef idx="minor">
-            <a:schemeClr val="lt1"/>
-          </a:fontRef>
-        </p:style>
-        <p:txBody>
-          <a:bodyPr rtlCol="0" anchor="ctr"/>
-          <a:lstStyle/>
-          <a:p>
-            <a:pPr algn="ctr"/>
-          </a:p>
-        </p:txBody>
-      </p:sp>
-      <p:sp>
-        <p:nvSpPr>
-          <p:cNvPr id="13" name="TextBox 12"/>
-          <p:cNvSpPr txBox="1"/>
-          <p:nvPr/>
-        </p:nvSpPr>
-        <p:spPr>
-          <a:xfrm>
-            <a:off x="8686800" y="3913632"/>
-            <a:ext cx="2743200" cy="457200"/>
-          </a:xfrm>
-          <a:prstGeom prst="rect">
-            <a:avLst/>
-          </a:prstGeom>
-          <a:noFill/>
-        </p:spPr>
-        <p:txBody>
-          <a:bodyPr wrap="square">
-            <a:spAutoFit/>
-          </a:bodyPr>
-          <a:lstStyle/>
-          <a:p>
-            <a:pPr algn="l"/>
-            <a:r>
-              <a:rPr sz="2600" b="1">
-                <a:solidFill>
-                  <a:srgbClr val="0B3D91"/>
-                </a:solidFill>
-                <a:latin typeface="Helvetica Neue"/>
-              </a:rPr>
-              <a:t>67.5M</a:t>
-            </a:r>
-          </a:p>
-        </p:txBody>
-      </p:sp>
-      <p:sp>
-        <p:nvSpPr>
-          <p:cNvPr id="14" name="TextBox 13"/>
-          <p:cNvSpPr txBox="1"/>
-          <p:nvPr/>
-        </p:nvSpPr>
-        <p:spPr>
-          <a:xfrm>
-            <a:off x="8686800" y="4370832"/>
-            <a:ext cx="2743200" cy="320040"/>
-          </a:xfrm>
-          <a:prstGeom prst="rect">
-            <a:avLst/>
-          </a:prstGeom>
-          <a:noFill/>
-        </p:spPr>
-        <p:txBody>
-          <a:bodyPr wrap="square">
-            <a:spAutoFit/>
-          </a:bodyPr>
-          <a:lstStyle/>
-          <a:p>
-            <a:pPr algn="l"/>
-            <a:r>
-              <a:rPr sz="1200" b="0">
-                <a:solidFill>
-                  <a:srgbClr val="52514E"/>
-                </a:solidFill>
-                <a:latin typeface="Helvetica Neue"/>
-              </a:rPr>
-              <a:t>total tokens processed</a:t>
-            </a:r>
-          </a:p>
-        </p:txBody>
-      </p:sp>
-      <p:sp>
-        <p:nvSpPr>
-          <p:cNvPr id="15" name="Rectangle 14"/>
-          <p:cNvSpPr/>
-          <p:nvPr/>
-        </p:nvSpPr>
-        <p:spPr>
-          <a:xfrm>
-            <a:off x="8503920" y="4983480"/>
-            <a:ext cx="3017520" cy="914400"/>
-          </a:xfrm>
-          <a:prstGeom prst="rect">
-            <a:avLst/>
-          </a:prstGeom>
-          <a:solidFill>
-            <a:srgbClr val="FFFFFF"/>
-          </a:solidFill>
-          <a:ln>
-            <a:noFill/>
-          </a:ln>
-          <a:effectLst/>
-        </p:spPr>
-        <p:style>
-          <a:lnRef idx="1">
-            <a:schemeClr val="accent1"/>
-          </a:lnRef>
-          <a:fillRef idx="3">
-            <a:schemeClr val="accent1"/>
-          </a:fillRef>
-          <a:effectRef idx="2">
-            <a:schemeClr val="accent1"/>
-          </a:effectRef>
-          <a:fontRef idx="minor">
-            <a:schemeClr val="lt1"/>
-          </a:fontRef>
-        </p:style>
-        <p:txBody>
-          <a:bodyPr rtlCol="0" anchor="ctr"/>
-          <a:lstStyle/>
-          <a:p>
-            <a:pPr algn="ctr"/>
-          </a:p>
-        </p:txBody>
-      </p:sp>
-      <p:sp>
-        <p:nvSpPr>
-          <p:cNvPr id="16" name="TextBox 15"/>
-          <p:cNvSpPr txBox="1"/>
-          <p:nvPr/>
-        </p:nvSpPr>
-        <p:spPr>
-          <a:xfrm>
-            <a:off x="8686800" y="5056632"/>
-            <a:ext cx="2743200" cy="457200"/>
-          </a:xfrm>
-          <a:prstGeom prst="rect">
-            <a:avLst/>
-          </a:prstGeom>
-          <a:noFill/>
-        </p:spPr>
-        <p:txBody>
-          <a:bodyPr wrap="square">
-            <a:spAutoFit/>
-          </a:bodyPr>
-          <a:lstStyle/>
-          <a:p>
-            <a:pPr algn="l"/>
-            <a:r>
-              <a:rPr sz="2600" b="1">
-                <a:solidFill>
-                  <a:srgbClr val="0B3D91"/>
-                </a:solidFill>
-                <a:latin typeface="Helvetica Neue"/>
-              </a:rPr>
-              <a:t>~$12.51</a:t>
-            </a:r>
-          </a:p>
-        </p:txBody>
-      </p:sp>
-      <p:sp>
-        <p:nvSpPr>
-          <p:cNvPr id="17" name="TextBox 16"/>
-          <p:cNvSpPr txBox="1"/>
-          <p:nvPr/>
-        </p:nvSpPr>
-        <p:spPr>
-          <a:xfrm>
-            <a:off x="8686800" y="5513832"/>
-            <a:ext cx="2743200" cy="320040"/>
-          </a:xfrm>
-          <a:prstGeom prst="rect">
-            <a:avLst/>
-          </a:prstGeom>
-          <a:noFill/>
-        </p:spPr>
-        <p:txBody>
-          <a:bodyPr wrap="square">
-            <a:spAutoFit/>
-          </a:bodyPr>
-          <a:lstStyle/>
-          <a:p>
-            <a:pPr algn="l"/>
-            <a:r>
-              <a:rPr sz="1200" b="0">
-                <a:solidFill>
-                  <a:srgbClr val="52514E"/>
-                </a:solidFill>
-                <a:latin typeface="Helvetica Neue"/>
-              </a:rPr>
-              <a:t>estimated Bedrock spend</a:t>
-            </a:r>
-          </a:p>
-        </p:txBody>
-      </p:sp>
     </p:spTree>
   </p:cSld>
   <p:clrMapOvr>
@@ -4492,8 +4037,8 @@
         </p:nvSpPr>
         <p:spPr>
           <a:xfrm>
-            <a:off x="640080" y="457200"/>
-            <a:ext cx="10515600" cy="640080"/>
+            <a:off x="640080" y="411480"/>
+            <a:ext cx="9144000" cy="548640"/>
           </a:xfrm>
           <a:prstGeom prst="rect">
             <a:avLst/>
@@ -4514,7 +4059,7 @@
                 </a:solidFill>
                 <a:latin typeface="Helvetica Neue"/>
               </a:rPr>
-              <a:t>The judge test: real TfL data is noisy</a:t>
+              <a:t>Token usage: totals for today</a:t>
             </a:r>
           </a:p>
         </p:txBody>
@@ -4527,8 +4072,8 @@
         </p:nvSpPr>
         <p:spPr>
           <a:xfrm>
-            <a:off x="731520" y="1371600"/>
-            <a:ext cx="10698480" cy="4846320"/>
+            <a:off x="640080" y="914400"/>
+            <a:ext cx="10515600" cy="457200"/>
           </a:xfrm>
           <a:prstGeom prst="rect">
             <a:avLst/>
@@ -4541,103 +4086,495 @@
           </a:bodyPr>
           <a:lstStyle/>
           <a:p>
-            <a:pPr>
-              <a:spcAft>
-                <a:spcPts val="1600"/>
-              </a:spcAft>
-            </a:pPr>
-            <a:r>
-              <a:rPr sz="1700" b="1">
-                <a:solidFill>
-                  <a:srgbClr val="2A78D6"/>
-                </a:solidFill>
-                <a:latin typeface="Helvetica Neue"/>
-              </a:rPr>
-              <a:t>What it is:  </a:t>
-            </a:r>
-            <a:r>
-              <a:rPr sz="1700">
-                <a:solidFill>
-                  <a:srgbClr val="1A1A1A"/>
-                </a:solidFill>
-                <a:latin typeface="Helvetica Neue"/>
-              </a:rPr>
-              <a:t>the same Hammersmith → Liverpool Street query run against every checkpoint, live, against whatever TfL's network was actually doing at that moment.</a:t>
-            </a:r>
-          </a:p>
-          <a:p>
-            <a:pPr>
-              <a:spcAft>
-                <a:spcPts val="1600"/>
-              </a:spcAft>
-            </a:pPr>
-            <a:r>
-              <a:rPr sz="1700" b="1">
-                <a:solidFill>
-                  <a:srgbClr val="2A78D6"/>
-                </a:solidFill>
-                <a:latin typeface="Helvetica Neue"/>
-              </a:rPr>
-              <a:t>What it showed:  </a:t>
-            </a:r>
-            <a:r>
-              <a:rPr sz="1700">
-                <a:solidFill>
-                  <a:srgbClr val="1A1A1A"/>
-                </a:solidFill>
-                <a:latin typeface="Helvetica Neue"/>
-              </a:rPr>
-              <a:t>the Hammersmith &amp; City line was genuinely running Minor Delays all session — but TfL's own journey planner quietly routes around it, and the agent doesn't always pick the same alternative twice. One run recommended the Circle line as a detour; another found the usual route was already Circle, so nothing needed to change.</a:t>
-            </a:r>
-          </a:p>
-          <a:p>
-            <a:pPr>
-              <a:spcAft>
-                <a:spcPts val="1600"/>
-              </a:spcAft>
-            </a:pPr>
-            <a:r>
-              <a:rPr sz="1700" b="1">
-                <a:solidFill>
-                  <a:srgbClr val="2A78D6"/>
-                </a:solidFill>
-                <a:latin typeface="Helvetica Neue"/>
-              </a:rPr>
-              <a:t>Why that matters:  </a:t>
-            </a:r>
-            <a:r>
-              <a:rPr sz="1700">
-                <a:solidFill>
-                  <a:srgbClr val="1A1A1A"/>
-                </a:solidFill>
-                <a:latin typeface="Helvetica Neue"/>
-              </a:rPr>
-              <a:t>it's real evidence the agent is reasoning over live data rather than following a script — but it also means a live disruption can't be relied on to reliably reproduce for a demo.</a:t>
-            </a:r>
-          </a:p>
-          <a:p>
-            <a:pPr>
-              <a:spcAft>
-                <a:spcPts val="1600"/>
-              </a:spcAft>
-            </a:pPr>
-            <a:r>
-              <a:rPr sz="1700" b="1">
-                <a:solidFill>
-                  <a:srgbClr val="2A78D6"/>
-                </a:solidFill>
-                <a:latin typeface="Helvetica Neue"/>
-              </a:rPr>
-              <a:t>The fix:  </a:t>
-            </a:r>
-            <a:r>
-              <a:rPr sz="1700">
-                <a:solidFill>
-                  <a:srgbClr val="1A1A1A"/>
-                </a:solidFill>
-                <a:latin typeface="Helvetica Neue"/>
-              </a:rPr>
-              <a:t>exactly the motivation for demo mode, on the next slide.</a:t>
+            <a:pPr algn="l"/>
+            <a:r>
+              <a:rPr sz="1400" b="0">
+                <a:solidFill>
+                  <a:srgbClr val="52514E"/>
+                </a:solidFill>
+                <a:latin typeface="Helvetica Neue"/>
+              </a:rPr>
+              <a:t>Pulled from local Claude Code session transcripts for today (all assistant turns, deduped by message id).</a:t>
+            </a:r>
+          </a:p>
+        </p:txBody>
+      </p:sp>
+      <p:pic>
+        <p:nvPicPr>
+          <p:cNvPr id="5" name="Picture 4" descr="usage_chart.png"/>
+          <p:cNvPicPr>
+            <a:picLocks noChangeAspect="1"/>
+          </p:cNvPicPr>
+          <p:nvPr/>
+        </p:nvPicPr>
+        <p:blipFill>
+          <a:blip r:embed="rId2"/>
+          <a:stretch>
+            <a:fillRect/>
+          </a:stretch>
+        </p:blipFill>
+        <p:spPr>
+          <a:xfrm>
+            <a:off x="548640" y="2000873"/>
+            <a:ext cx="7680960" cy="3770653"/>
+          </a:xfrm>
+          <a:prstGeom prst="rect">
+            <a:avLst/>
+          </a:prstGeom>
+        </p:spPr>
+      </p:pic>
+      <p:sp>
+        <p:nvSpPr>
+          <p:cNvPr id="6" name="Rectangle 5"/>
+          <p:cNvSpPr/>
+          <p:nvPr/>
+        </p:nvSpPr>
+        <p:spPr>
+          <a:xfrm>
+            <a:off x="8503920" y="1554480"/>
+            <a:ext cx="3017520" cy="914400"/>
+          </a:xfrm>
+          <a:prstGeom prst="rect">
+            <a:avLst/>
+          </a:prstGeom>
+          <a:solidFill>
+            <a:srgbClr val="FFFFFF"/>
+          </a:solidFill>
+          <a:ln>
+            <a:noFill/>
+          </a:ln>
+          <a:effectLst/>
+        </p:spPr>
+        <p:style>
+          <a:lnRef idx="1">
+            <a:schemeClr val="accent1"/>
+          </a:lnRef>
+          <a:fillRef idx="3">
+            <a:schemeClr val="accent1"/>
+          </a:fillRef>
+          <a:effectRef idx="2">
+            <a:schemeClr val="accent1"/>
+          </a:effectRef>
+          <a:fontRef idx="minor">
+            <a:schemeClr val="lt1"/>
+          </a:fontRef>
+        </p:style>
+        <p:txBody>
+          <a:bodyPr rtlCol="0" anchor="ctr"/>
+          <a:lstStyle/>
+          <a:p>
+            <a:pPr algn="ctr"/>
+          </a:p>
+        </p:txBody>
+      </p:sp>
+      <p:sp>
+        <p:nvSpPr>
+          <p:cNvPr id="7" name="TextBox 6"/>
+          <p:cNvSpPr txBox="1"/>
+          <p:nvPr/>
+        </p:nvSpPr>
+        <p:spPr>
+          <a:xfrm>
+            <a:off x="8686800" y="1627632"/>
+            <a:ext cx="2743200" cy="457200"/>
+          </a:xfrm>
+          <a:prstGeom prst="rect">
+            <a:avLst/>
+          </a:prstGeom>
+          <a:noFill/>
+        </p:spPr>
+        <p:txBody>
+          <a:bodyPr wrap="square">
+            <a:spAutoFit/>
+          </a:bodyPr>
+          <a:lstStyle/>
+          <a:p>
+            <a:pPr algn="l"/>
+            <a:r>
+              <a:rPr sz="2600" b="1">
+                <a:solidFill>
+                  <a:srgbClr val="0B3D91"/>
+                </a:solidFill>
+                <a:latin typeface="Helvetica Neue"/>
+              </a:rPr>
+              <a:t>1,423</a:t>
+            </a:r>
+          </a:p>
+        </p:txBody>
+      </p:sp>
+      <p:sp>
+        <p:nvSpPr>
+          <p:cNvPr id="8" name="TextBox 7"/>
+          <p:cNvSpPr txBox="1"/>
+          <p:nvPr/>
+        </p:nvSpPr>
+        <p:spPr>
+          <a:xfrm>
+            <a:off x="8686800" y="2084832"/>
+            <a:ext cx="2743200" cy="320040"/>
+          </a:xfrm>
+          <a:prstGeom prst="rect">
+            <a:avLst/>
+          </a:prstGeom>
+          <a:noFill/>
+        </p:spPr>
+        <p:txBody>
+          <a:bodyPr wrap="square">
+            <a:spAutoFit/>
+          </a:bodyPr>
+          <a:lstStyle/>
+          <a:p>
+            <a:pPr algn="l"/>
+            <a:r>
+              <a:rPr sz="1200" b="0">
+                <a:solidFill>
+                  <a:srgbClr val="52514E"/>
+                </a:solidFill>
+                <a:latin typeface="Helvetica Neue"/>
+              </a:rPr>
+              <a:t>model turns</a:t>
+            </a:r>
+          </a:p>
+        </p:txBody>
+      </p:sp>
+      <p:sp>
+        <p:nvSpPr>
+          <p:cNvPr id="9" name="Rectangle 8"/>
+          <p:cNvSpPr/>
+          <p:nvPr/>
+        </p:nvSpPr>
+        <p:spPr>
+          <a:xfrm>
+            <a:off x="8503920" y="2697480"/>
+            <a:ext cx="3017520" cy="914400"/>
+          </a:xfrm>
+          <a:prstGeom prst="rect">
+            <a:avLst/>
+          </a:prstGeom>
+          <a:solidFill>
+            <a:srgbClr val="FFFFFF"/>
+          </a:solidFill>
+          <a:ln>
+            <a:noFill/>
+          </a:ln>
+          <a:effectLst/>
+        </p:spPr>
+        <p:style>
+          <a:lnRef idx="1">
+            <a:schemeClr val="accent1"/>
+          </a:lnRef>
+          <a:fillRef idx="3">
+            <a:schemeClr val="accent1"/>
+          </a:fillRef>
+          <a:effectRef idx="2">
+            <a:schemeClr val="accent1"/>
+          </a:effectRef>
+          <a:fontRef idx="minor">
+            <a:schemeClr val="lt1"/>
+          </a:fontRef>
+        </p:style>
+        <p:txBody>
+          <a:bodyPr rtlCol="0" anchor="ctr"/>
+          <a:lstStyle/>
+          <a:p>
+            <a:pPr algn="ctr"/>
+          </a:p>
+        </p:txBody>
+      </p:sp>
+      <p:sp>
+        <p:nvSpPr>
+          <p:cNvPr id="10" name="TextBox 9"/>
+          <p:cNvSpPr txBox="1"/>
+          <p:nvPr/>
+        </p:nvSpPr>
+        <p:spPr>
+          <a:xfrm>
+            <a:off x="8686800" y="2770632"/>
+            <a:ext cx="2743200" cy="457200"/>
+          </a:xfrm>
+          <a:prstGeom prst="rect">
+            <a:avLst/>
+          </a:prstGeom>
+          <a:noFill/>
+        </p:spPr>
+        <p:txBody>
+          <a:bodyPr wrap="square">
+            <a:spAutoFit/>
+          </a:bodyPr>
+          <a:lstStyle/>
+          <a:p>
+            <a:pPr algn="l"/>
+            <a:r>
+              <a:rPr sz="2600" b="1">
+                <a:solidFill>
+                  <a:srgbClr val="0B3D91"/>
+                </a:solidFill>
+                <a:latin typeface="Helvetica Neue"/>
+              </a:rPr>
+              <a:t>797K</a:t>
+            </a:r>
+          </a:p>
+        </p:txBody>
+      </p:sp>
+      <p:sp>
+        <p:nvSpPr>
+          <p:cNvPr id="11" name="TextBox 10"/>
+          <p:cNvSpPr txBox="1"/>
+          <p:nvPr/>
+        </p:nvSpPr>
+        <p:spPr>
+          <a:xfrm>
+            <a:off x="8686800" y="3227832"/>
+            <a:ext cx="2743200" cy="320040"/>
+          </a:xfrm>
+          <a:prstGeom prst="rect">
+            <a:avLst/>
+          </a:prstGeom>
+          <a:noFill/>
+        </p:spPr>
+        <p:txBody>
+          <a:bodyPr wrap="square">
+            <a:spAutoFit/>
+          </a:bodyPr>
+          <a:lstStyle/>
+          <a:p>
+            <a:pPr algn="l"/>
+            <a:r>
+              <a:rPr sz="1200" b="0">
+                <a:solidFill>
+                  <a:srgbClr val="52514E"/>
+                </a:solidFill>
+                <a:latin typeface="Helvetica Neue"/>
+              </a:rPr>
+              <a:t>output tokens</a:t>
+            </a:r>
+          </a:p>
+        </p:txBody>
+      </p:sp>
+      <p:sp>
+        <p:nvSpPr>
+          <p:cNvPr id="12" name="Rectangle 11"/>
+          <p:cNvSpPr/>
+          <p:nvPr/>
+        </p:nvSpPr>
+        <p:spPr>
+          <a:xfrm>
+            <a:off x="8503920" y="3840480"/>
+            <a:ext cx="3017520" cy="914400"/>
+          </a:xfrm>
+          <a:prstGeom prst="rect">
+            <a:avLst/>
+          </a:prstGeom>
+          <a:solidFill>
+            <a:srgbClr val="FFFFFF"/>
+          </a:solidFill>
+          <a:ln>
+            <a:noFill/>
+          </a:ln>
+          <a:effectLst/>
+        </p:spPr>
+        <p:style>
+          <a:lnRef idx="1">
+            <a:schemeClr val="accent1"/>
+          </a:lnRef>
+          <a:fillRef idx="3">
+            <a:schemeClr val="accent1"/>
+          </a:fillRef>
+          <a:effectRef idx="2">
+            <a:schemeClr val="accent1"/>
+          </a:effectRef>
+          <a:fontRef idx="minor">
+            <a:schemeClr val="lt1"/>
+          </a:fontRef>
+        </p:style>
+        <p:txBody>
+          <a:bodyPr rtlCol="0" anchor="ctr"/>
+          <a:lstStyle/>
+          <a:p>
+            <a:pPr algn="ctr"/>
+          </a:p>
+        </p:txBody>
+      </p:sp>
+      <p:sp>
+        <p:nvSpPr>
+          <p:cNvPr id="13" name="TextBox 12"/>
+          <p:cNvSpPr txBox="1"/>
+          <p:nvPr/>
+        </p:nvSpPr>
+        <p:spPr>
+          <a:xfrm>
+            <a:off x="8686800" y="3913632"/>
+            <a:ext cx="2743200" cy="457200"/>
+          </a:xfrm>
+          <a:prstGeom prst="rect">
+            <a:avLst/>
+          </a:prstGeom>
+          <a:noFill/>
+        </p:spPr>
+        <p:txBody>
+          <a:bodyPr wrap="square">
+            <a:spAutoFit/>
+          </a:bodyPr>
+          <a:lstStyle/>
+          <a:p>
+            <a:pPr algn="l"/>
+            <a:r>
+              <a:rPr sz="2600" b="1">
+                <a:solidFill>
+                  <a:srgbClr val="0B3D91"/>
+                </a:solidFill>
+                <a:latin typeface="Helvetica Neue"/>
+              </a:rPr>
+              <a:t>133.5M</a:t>
+            </a:r>
+          </a:p>
+        </p:txBody>
+      </p:sp>
+      <p:sp>
+        <p:nvSpPr>
+          <p:cNvPr id="14" name="TextBox 13"/>
+          <p:cNvSpPr txBox="1"/>
+          <p:nvPr/>
+        </p:nvSpPr>
+        <p:spPr>
+          <a:xfrm>
+            <a:off x="8686800" y="4370832"/>
+            <a:ext cx="2743200" cy="320040"/>
+          </a:xfrm>
+          <a:prstGeom prst="rect">
+            <a:avLst/>
+          </a:prstGeom>
+          <a:noFill/>
+        </p:spPr>
+        <p:txBody>
+          <a:bodyPr wrap="square">
+            <a:spAutoFit/>
+          </a:bodyPr>
+          <a:lstStyle/>
+          <a:p>
+            <a:pPr algn="l"/>
+            <a:r>
+              <a:rPr sz="1200" b="0">
+                <a:solidFill>
+                  <a:srgbClr val="52514E"/>
+                </a:solidFill>
+                <a:latin typeface="Helvetica Neue"/>
+              </a:rPr>
+              <a:t>total tokens processed</a:t>
+            </a:r>
+          </a:p>
+        </p:txBody>
+      </p:sp>
+      <p:sp>
+        <p:nvSpPr>
+          <p:cNvPr id="15" name="Rectangle 14"/>
+          <p:cNvSpPr/>
+          <p:nvPr/>
+        </p:nvSpPr>
+        <p:spPr>
+          <a:xfrm>
+            <a:off x="8503920" y="4983480"/>
+            <a:ext cx="3017520" cy="914400"/>
+          </a:xfrm>
+          <a:prstGeom prst="rect">
+            <a:avLst/>
+          </a:prstGeom>
+          <a:solidFill>
+            <a:srgbClr val="FFFFFF"/>
+          </a:solidFill>
+          <a:ln>
+            <a:noFill/>
+          </a:ln>
+          <a:effectLst/>
+        </p:spPr>
+        <p:style>
+          <a:lnRef idx="1">
+            <a:schemeClr val="accent1"/>
+          </a:lnRef>
+          <a:fillRef idx="3">
+            <a:schemeClr val="accent1"/>
+          </a:fillRef>
+          <a:effectRef idx="2">
+            <a:schemeClr val="accent1"/>
+          </a:effectRef>
+          <a:fontRef idx="minor">
+            <a:schemeClr val="lt1"/>
+          </a:fontRef>
+        </p:style>
+        <p:txBody>
+          <a:bodyPr rtlCol="0" anchor="ctr"/>
+          <a:lstStyle/>
+          <a:p>
+            <a:pPr algn="ctr"/>
+          </a:p>
+        </p:txBody>
+      </p:sp>
+      <p:sp>
+        <p:nvSpPr>
+          <p:cNvPr id="16" name="TextBox 15"/>
+          <p:cNvSpPr txBox="1"/>
+          <p:nvPr/>
+        </p:nvSpPr>
+        <p:spPr>
+          <a:xfrm>
+            <a:off x="8686800" y="5056632"/>
+            <a:ext cx="2743200" cy="457200"/>
+          </a:xfrm>
+          <a:prstGeom prst="rect">
+            <a:avLst/>
+          </a:prstGeom>
+          <a:noFill/>
+        </p:spPr>
+        <p:txBody>
+          <a:bodyPr wrap="square">
+            <a:spAutoFit/>
+          </a:bodyPr>
+          <a:lstStyle/>
+          <a:p>
+            <a:pPr algn="l"/>
+            <a:r>
+              <a:rPr sz="2600" b="1">
+                <a:solidFill>
+                  <a:srgbClr val="0B3D91"/>
+                </a:solidFill>
+                <a:latin typeface="Helvetica Neue"/>
+              </a:rPr>
+              <a:t>~$22.72</a:t>
+            </a:r>
+          </a:p>
+        </p:txBody>
+      </p:sp>
+      <p:sp>
+        <p:nvSpPr>
+          <p:cNvPr id="17" name="TextBox 16"/>
+          <p:cNvSpPr txBox="1"/>
+          <p:nvPr/>
+        </p:nvSpPr>
+        <p:spPr>
+          <a:xfrm>
+            <a:off x="8686800" y="5513832"/>
+            <a:ext cx="2743200" cy="320040"/>
+          </a:xfrm>
+          <a:prstGeom prst="rect">
+            <a:avLst/>
+          </a:prstGeom>
+          <a:noFill/>
+        </p:spPr>
+        <p:txBody>
+          <a:bodyPr wrap="square">
+            <a:spAutoFit/>
+          </a:bodyPr>
+          <a:lstStyle/>
+          <a:p>
+            <a:pPr algn="l"/>
+            <a:r>
+              <a:rPr sz="1200" b="0">
+                <a:solidFill>
+                  <a:srgbClr val="52514E"/>
+                </a:solidFill>
+                <a:latin typeface="Helvetica Neue"/>
+              </a:rPr>
+              <a:t>estimated Bedrock spend</a:t>
             </a:r>
           </a:p>
         </p:txBody>
@@ -4712,8 +4649,8 @@
         </p:nvSpPr>
         <p:spPr>
           <a:xfrm>
-            <a:off x="640080" y="411480"/>
-            <a:ext cx="9144000" cy="548640"/>
+            <a:off x="640080" y="457200"/>
+            <a:ext cx="10515600" cy="640080"/>
           </a:xfrm>
           <a:prstGeom prst="rect">
             <a:avLst/>
@@ -4734,7 +4671,7 @@
                 </a:solidFill>
                 <a:latin typeface="Helvetica Neue"/>
               </a:rPr>
-              <a:t>New: Demo mode</a:t>
+              <a:t>The judge test: real TfL data is noisy</a:t>
             </a:r>
           </a:p>
         </p:txBody>
@@ -4747,8 +4684,8 @@
         </p:nvSpPr>
         <p:spPr>
           <a:xfrm>
-            <a:off x="640080" y="914400"/>
-            <a:ext cx="10698480" cy="548640"/>
+            <a:off x="731520" y="1371600"/>
+            <a:ext cx="10698480" cy="4846320"/>
           </a:xfrm>
           <a:prstGeom prst="rect">
             <a:avLst/>
@@ -4761,294 +4698,103 @@
           </a:bodyPr>
           <a:lstStyle/>
           <a:p>
-            <a:pPr algn="l"/>
-            <a:r>
-              <a:rPr sz="1400" b="0">
-                <a:solidFill>
-                  <a:srgbClr val="52514E"/>
-                </a:solidFill>
-                <a:latin typeface="Helvetica Neue"/>
-              </a:rPr>
-              <a:t>A dev panel (profile menu → Demo mode) that injects a synthetic disruption so a live demo doesn't depend on TfL actually having a bad day.</a:t>
-            </a:r>
-          </a:p>
-        </p:txBody>
-      </p:sp>
-      <p:sp>
-        <p:nvSpPr>
-          <p:cNvPr id="5" name="Rectangle 4"/>
-          <p:cNvSpPr/>
-          <p:nvPr/>
-        </p:nvSpPr>
-        <p:spPr>
-          <a:xfrm>
-            <a:off x="640080" y="1874519"/>
-            <a:ext cx="5349240" cy="2331720"/>
-          </a:xfrm>
-          <a:prstGeom prst="rect">
-            <a:avLst/>
-          </a:prstGeom>
-          <a:solidFill>
-            <a:srgbClr val="FFFFFF"/>
-          </a:solidFill>
-          <a:ln>
-            <a:noFill/>
-          </a:ln>
-          <a:effectLst/>
-        </p:spPr>
-        <p:style>
-          <a:lnRef idx="1">
-            <a:schemeClr val="accent1"/>
-          </a:lnRef>
-          <a:fillRef idx="3">
-            <a:schemeClr val="accent1"/>
-          </a:fillRef>
-          <a:effectRef idx="2">
-            <a:schemeClr val="accent1"/>
-          </a:effectRef>
-          <a:fontRef idx="minor">
-            <a:schemeClr val="lt1"/>
-          </a:fontRef>
-        </p:style>
-        <p:txBody>
-          <a:bodyPr rtlCol="0" anchor="ctr"/>
-          <a:lstStyle/>
-          <a:p>
-            <a:pPr algn="ctr"/>
-          </a:p>
-        </p:txBody>
-      </p:sp>
-      <p:pic>
-        <p:nvPicPr>
-          <p:cNvPr id="6" name="Picture 5" descr="demo_panel_desktop.png"/>
-          <p:cNvPicPr>
-            <a:picLocks noChangeAspect="1"/>
-          </p:cNvPicPr>
-          <p:nvPr/>
-        </p:nvPicPr>
-        <p:blipFill>
-          <a:blip r:embed="rId2"/>
-          <a:stretch>
-            <a:fillRect/>
-          </a:stretch>
-        </p:blipFill>
-        <p:spPr>
-          <a:xfrm>
-            <a:off x="1921136" y="1947671"/>
-            <a:ext cx="2787128" cy="1965960"/>
-          </a:xfrm>
-          <a:prstGeom prst="rect">
-            <a:avLst/>
-          </a:prstGeom>
-        </p:spPr>
-      </p:pic>
-      <p:sp>
-        <p:nvSpPr>
-          <p:cNvPr id="7" name="TextBox 6"/>
-          <p:cNvSpPr txBox="1"/>
-          <p:nvPr/>
-        </p:nvSpPr>
-        <p:spPr>
-          <a:xfrm>
-            <a:off x="749808" y="3950207"/>
-            <a:ext cx="5129784" cy="228600"/>
-          </a:xfrm>
-          <a:prstGeom prst="rect">
-            <a:avLst/>
-          </a:prstGeom>
-          <a:noFill/>
-        </p:spPr>
-        <p:txBody>
-          <a:bodyPr wrap="square">
-            <a:spAutoFit/>
-          </a:bodyPr>
-          <a:lstStyle/>
-          <a:p>
-            <a:pPr algn="l"/>
-            <a:r>
-              <a:rPr sz="1050" b="1">
-                <a:solidFill>
-                  <a:srgbClr val="52514E"/>
-                </a:solidFill>
-                <a:latin typeface="Helvetica Neue"/>
-              </a:rPr>
-              <a:t>Preset picker, under the profile avatar</a:t>
-            </a:r>
-          </a:p>
-        </p:txBody>
-      </p:sp>
-      <p:sp>
-        <p:nvSpPr>
-          <p:cNvPr id="8" name="Rectangle 7"/>
-          <p:cNvSpPr/>
-          <p:nvPr/>
-        </p:nvSpPr>
-        <p:spPr>
-          <a:xfrm>
-            <a:off x="6172200" y="1874519"/>
-            <a:ext cx="5349240" cy="2331720"/>
-          </a:xfrm>
-          <a:prstGeom prst="rect">
-            <a:avLst/>
-          </a:prstGeom>
-          <a:solidFill>
-            <a:srgbClr val="FFFFFF"/>
-          </a:solidFill>
-          <a:ln>
-            <a:noFill/>
-          </a:ln>
-          <a:effectLst/>
-        </p:spPr>
-        <p:style>
-          <a:lnRef idx="1">
-            <a:schemeClr val="accent1"/>
-          </a:lnRef>
-          <a:fillRef idx="3">
-            <a:schemeClr val="accent1"/>
-          </a:fillRef>
-          <a:effectRef idx="2">
-            <a:schemeClr val="accent1"/>
-          </a:effectRef>
-          <a:fontRef idx="minor">
-            <a:schemeClr val="lt1"/>
-          </a:fontRef>
-        </p:style>
-        <p:txBody>
-          <a:bodyPr rtlCol="0" anchor="ctr"/>
-          <a:lstStyle/>
-          <a:p>
-            <a:pPr algn="ctr"/>
-          </a:p>
-        </p:txBody>
-      </p:sp>
-      <p:pic>
-        <p:nvPicPr>
-          <p:cNvPr id="9" name="Picture 8" descr="demo_verdict_desktop.png"/>
-          <p:cNvPicPr>
-            <a:picLocks noChangeAspect="1"/>
-          </p:cNvPicPr>
-          <p:nvPr/>
-        </p:nvPicPr>
-        <p:blipFill>
-          <a:blip r:embed="rId3"/>
-          <a:stretch>
-            <a:fillRect/>
-          </a:stretch>
-        </p:blipFill>
-        <p:spPr>
-          <a:xfrm>
-            <a:off x="7468667" y="1947671"/>
-            <a:ext cx="2756306" cy="1965960"/>
-          </a:xfrm>
-          <a:prstGeom prst="rect">
-            <a:avLst/>
-          </a:prstGeom>
-        </p:spPr>
-      </p:pic>
-      <p:sp>
-        <p:nvSpPr>
-          <p:cNvPr id="10" name="TextBox 9"/>
-          <p:cNvSpPr txBox="1"/>
-          <p:nvPr/>
-        </p:nvSpPr>
-        <p:spPr>
-          <a:xfrm>
-            <a:off x="6281928" y="3950207"/>
-            <a:ext cx="5129784" cy="228600"/>
-          </a:xfrm>
-          <a:prstGeom prst="rect">
-            <a:avLst/>
-          </a:prstGeom>
-          <a:noFill/>
-        </p:spPr>
-        <p:txBody>
-          <a:bodyPr wrap="square">
-            <a:spAutoFit/>
-          </a:bodyPr>
-          <a:lstStyle/>
-          <a:p>
-            <a:pPr algn="l"/>
-            <a:r>
-              <a:rPr sz="1050" b="1">
-                <a:solidFill>
-                  <a:srgbClr val="52514E"/>
-                </a:solidFill>
-                <a:latin typeface="Helvetica Neue"/>
-              </a:rPr>
-              <a:t>Resulting verdict: Central line, Severe Delays</a:t>
-            </a:r>
-          </a:p>
-        </p:txBody>
-      </p:sp>
-      <p:sp>
-        <p:nvSpPr>
-          <p:cNvPr id="11" name="TextBox 10"/>
-          <p:cNvSpPr txBox="1"/>
-          <p:nvPr/>
-        </p:nvSpPr>
-        <p:spPr>
-          <a:xfrm>
-            <a:off x="731520" y="4572000"/>
-            <a:ext cx="10698480" cy="1737360"/>
-          </a:xfrm>
-          <a:prstGeom prst="rect">
-            <a:avLst/>
-          </a:prstGeom>
-          <a:noFill/>
-        </p:spPr>
-        <p:txBody>
-          <a:bodyPr wrap="square">
-            <a:spAutoFit/>
-          </a:bodyPr>
-          <a:lstStyle/>
-          <a:p>
             <a:pPr>
               <a:spcAft>
-                <a:spcPts val="1000"/>
+                <a:spcPts val="1600"/>
               </a:spcAft>
             </a:pPr>
             <a:r>
-              <a:rPr sz="1500" b="1">
+              <a:rPr sz="1700" b="1">
                 <a:solidFill>
                   <a:srgbClr val="2A78D6"/>
                 </a:solidFill>
                 <a:latin typeface="Helvetica Neue"/>
               </a:rPr>
-              <a:t>How it stays honest:  </a:t>
-            </a:r>
-            <a:r>
-              <a:rPr sz="1500">
+              <a:t>What it is:  </a:t>
+            </a:r>
+            <a:r>
+              <a:rPr sz="1700">
                 <a:solidFill>
                   <a:srgbClr val="1A1A1A"/>
                 </a:solidFill>
                 <a:latin typeface="Helvetica Neue"/>
               </a:rPr>
-              <a:t>the fake status is only injected at the get_line_status / get_line_disruption_detail tools the agent calls — the model still reasons genuinely over it, it just isn't real TfL data.</a:t>
+              <a:t>the same Hammersmith → Liverpool Street query run against every checkpoint, live, against whatever TfL's network was actually doing at that moment.</a:t>
             </a:r>
           </a:p>
           <a:p>
             <a:pPr>
               <a:spcAft>
-                <a:spcPts val="1000"/>
+                <a:spcPts val="1600"/>
               </a:spcAft>
             </a:pPr>
             <a:r>
-              <a:rPr sz="1500" b="1">
+              <a:rPr sz="1700" b="1">
                 <a:solidFill>
                   <a:srgbClr val="2A78D6"/>
                 </a:solidFill>
                 <a:latin typeface="Helvetica Neue"/>
               </a:rPr>
-              <a:t>Full-page consistency:  </a:t>
-            </a:r>
-            <a:r>
-              <a:rPr sz="1500">
+              <a:t>What it showed:  </a:t>
+            </a:r>
+            <a:r>
+              <a:rPr sz="1700">
                 <a:solidFill>
                   <a:srgbClr val="1A1A1A"/>
                 </a:solidFill>
                 <a:latin typeface="Helvetica Neue"/>
               </a:rPr>
-              <a:t>the departure board ticker and the itinerary's per-leg "Disrupted" tag are overridden too, so the whole page agrees with the verdict instead of the text alone claiming a delay nothing else shows.</a:t>
+              <a:t>the Hammersmith &amp; City line was genuinely running Minor Delays all session — but TfL's own journey planner quietly routes around it, and the agent doesn't always pick the same alternative twice. One run recommended the Circle line as a detour; another found the usual route was already Circle, so nothing needed to change.</a:t>
+            </a:r>
+          </a:p>
+          <a:p>
+            <a:pPr>
+              <a:spcAft>
+                <a:spcPts val="1600"/>
+              </a:spcAft>
+            </a:pPr>
+            <a:r>
+              <a:rPr sz="1700" b="1">
+                <a:solidFill>
+                  <a:srgbClr val="2A78D6"/>
+                </a:solidFill>
+                <a:latin typeface="Helvetica Neue"/>
+              </a:rPr>
+              <a:t>Why that matters:  </a:t>
+            </a:r>
+            <a:r>
+              <a:rPr sz="1700">
+                <a:solidFill>
+                  <a:srgbClr val="1A1A1A"/>
+                </a:solidFill>
+                <a:latin typeface="Helvetica Neue"/>
+              </a:rPr>
+              <a:t>it's real evidence the agent is reasoning over live data rather than following a script — but it also means a live disruption can't be relied on to reliably reproduce for a demo.</a:t>
+            </a:r>
+          </a:p>
+          <a:p>
+            <a:pPr>
+              <a:spcAft>
+                <a:spcPts val="1600"/>
+              </a:spcAft>
+            </a:pPr>
+            <a:r>
+              <a:rPr sz="1700" b="1">
+                <a:solidFill>
+                  <a:srgbClr val="2A78D6"/>
+                </a:solidFill>
+                <a:latin typeface="Helvetica Neue"/>
+              </a:rPr>
+              <a:t>The fix:  </a:t>
+            </a:r>
+            <a:r>
+              <a:rPr sz="1700">
+                <a:solidFill>
+                  <a:srgbClr val="1A1A1A"/>
+                </a:solidFill>
+                <a:latin typeface="Helvetica Neue"/>
+              </a:rPr>
+              <a:t>exactly the motivation for demo mode, on the next slide.</a:t>
             </a:r>
           </a:p>
         </p:txBody>
@@ -5123,8 +4869,8 @@
         </p:nvSpPr>
         <p:spPr>
           <a:xfrm>
-            <a:off x="640080" y="457200"/>
-            <a:ext cx="10515600" cy="640080"/>
+            <a:off x="640080" y="411480"/>
+            <a:ext cx="9144000" cy="548640"/>
           </a:xfrm>
           <a:prstGeom prst="rect">
             <a:avLst/>
@@ -5145,7 +4891,7 @@
                 </a:solidFill>
                 <a:latin typeface="Helvetica Neue"/>
               </a:rPr>
-              <a:t>Under the hood: changes you can't screenshot</a:t>
+              <a:t>New: Demo mode</a:t>
             </a:r>
           </a:p>
         </p:txBody>
@@ -5158,8 +4904,8 @@
         </p:nvSpPr>
         <p:spPr>
           <a:xfrm>
-            <a:off x="731520" y="1371600"/>
-            <a:ext cx="10698480" cy="5029200"/>
+            <a:off x="640080" y="914400"/>
+            <a:ext cx="10698480" cy="548640"/>
           </a:xfrm>
           <a:prstGeom prst="rect">
             <a:avLst/>
@@ -5172,9 +4918,250 @@
           </a:bodyPr>
           <a:lstStyle/>
           <a:p>
+            <a:pPr algn="l"/>
+            <a:r>
+              <a:rPr sz="1400" b="0">
+                <a:solidFill>
+                  <a:srgbClr val="52514E"/>
+                </a:solidFill>
+                <a:latin typeface="Helvetica Neue"/>
+              </a:rPr>
+              <a:t>A dev panel (profile menu → Demo mode) that injects a synthetic disruption so a live demo doesn't depend on TfL actually having a bad day.</a:t>
+            </a:r>
+          </a:p>
+        </p:txBody>
+      </p:sp>
+      <p:sp>
+        <p:nvSpPr>
+          <p:cNvPr id="5" name="Rectangle 4"/>
+          <p:cNvSpPr/>
+          <p:nvPr/>
+        </p:nvSpPr>
+        <p:spPr>
+          <a:xfrm>
+            <a:off x="640080" y="1874519"/>
+            <a:ext cx="5349240" cy="2331720"/>
+          </a:xfrm>
+          <a:prstGeom prst="rect">
+            <a:avLst/>
+          </a:prstGeom>
+          <a:solidFill>
+            <a:srgbClr val="FFFFFF"/>
+          </a:solidFill>
+          <a:ln>
+            <a:noFill/>
+          </a:ln>
+          <a:effectLst/>
+        </p:spPr>
+        <p:style>
+          <a:lnRef idx="1">
+            <a:schemeClr val="accent1"/>
+          </a:lnRef>
+          <a:fillRef idx="3">
+            <a:schemeClr val="accent1"/>
+          </a:fillRef>
+          <a:effectRef idx="2">
+            <a:schemeClr val="accent1"/>
+          </a:effectRef>
+          <a:fontRef idx="minor">
+            <a:schemeClr val="lt1"/>
+          </a:fontRef>
+        </p:style>
+        <p:txBody>
+          <a:bodyPr rtlCol="0" anchor="ctr"/>
+          <a:lstStyle/>
+          <a:p>
+            <a:pPr algn="ctr"/>
+          </a:p>
+        </p:txBody>
+      </p:sp>
+      <p:pic>
+        <p:nvPicPr>
+          <p:cNvPr id="6" name="Picture 5" descr="demo_panel_desktop.png"/>
+          <p:cNvPicPr>
+            <a:picLocks noChangeAspect="1"/>
+          </p:cNvPicPr>
+          <p:nvPr/>
+        </p:nvPicPr>
+        <p:blipFill>
+          <a:blip r:embed="rId2"/>
+          <a:stretch>
+            <a:fillRect/>
+          </a:stretch>
+        </p:blipFill>
+        <p:spPr>
+          <a:xfrm>
+            <a:off x="1921136" y="1947671"/>
+            <a:ext cx="2787128" cy="1965960"/>
+          </a:xfrm>
+          <a:prstGeom prst="rect">
+            <a:avLst/>
+          </a:prstGeom>
+        </p:spPr>
+      </p:pic>
+      <p:sp>
+        <p:nvSpPr>
+          <p:cNvPr id="7" name="TextBox 6"/>
+          <p:cNvSpPr txBox="1"/>
+          <p:nvPr/>
+        </p:nvSpPr>
+        <p:spPr>
+          <a:xfrm>
+            <a:off x="749808" y="3950207"/>
+            <a:ext cx="5129784" cy="228600"/>
+          </a:xfrm>
+          <a:prstGeom prst="rect">
+            <a:avLst/>
+          </a:prstGeom>
+          <a:noFill/>
+        </p:spPr>
+        <p:txBody>
+          <a:bodyPr wrap="square">
+            <a:spAutoFit/>
+          </a:bodyPr>
+          <a:lstStyle/>
+          <a:p>
+            <a:pPr algn="l"/>
+            <a:r>
+              <a:rPr sz="1050" b="1">
+                <a:solidFill>
+                  <a:srgbClr val="52514E"/>
+                </a:solidFill>
+                <a:latin typeface="Helvetica Neue"/>
+              </a:rPr>
+              <a:t>Preset picker, under the profile avatar</a:t>
+            </a:r>
+          </a:p>
+        </p:txBody>
+      </p:sp>
+      <p:sp>
+        <p:nvSpPr>
+          <p:cNvPr id="8" name="Rectangle 7"/>
+          <p:cNvSpPr/>
+          <p:nvPr/>
+        </p:nvSpPr>
+        <p:spPr>
+          <a:xfrm>
+            <a:off x="6172200" y="1874519"/>
+            <a:ext cx="5349240" cy="2331720"/>
+          </a:xfrm>
+          <a:prstGeom prst="rect">
+            <a:avLst/>
+          </a:prstGeom>
+          <a:solidFill>
+            <a:srgbClr val="FFFFFF"/>
+          </a:solidFill>
+          <a:ln>
+            <a:noFill/>
+          </a:ln>
+          <a:effectLst/>
+        </p:spPr>
+        <p:style>
+          <a:lnRef idx="1">
+            <a:schemeClr val="accent1"/>
+          </a:lnRef>
+          <a:fillRef idx="3">
+            <a:schemeClr val="accent1"/>
+          </a:fillRef>
+          <a:effectRef idx="2">
+            <a:schemeClr val="accent1"/>
+          </a:effectRef>
+          <a:fontRef idx="minor">
+            <a:schemeClr val="lt1"/>
+          </a:fontRef>
+        </p:style>
+        <p:txBody>
+          <a:bodyPr rtlCol="0" anchor="ctr"/>
+          <a:lstStyle/>
+          <a:p>
+            <a:pPr algn="ctr"/>
+          </a:p>
+        </p:txBody>
+      </p:sp>
+      <p:pic>
+        <p:nvPicPr>
+          <p:cNvPr id="9" name="Picture 8" descr="demo_verdict_desktop.png"/>
+          <p:cNvPicPr>
+            <a:picLocks noChangeAspect="1"/>
+          </p:cNvPicPr>
+          <p:nvPr/>
+        </p:nvPicPr>
+        <p:blipFill>
+          <a:blip r:embed="rId3"/>
+          <a:stretch>
+            <a:fillRect/>
+          </a:stretch>
+        </p:blipFill>
+        <p:spPr>
+          <a:xfrm>
+            <a:off x="7468667" y="1947671"/>
+            <a:ext cx="2756306" cy="1965960"/>
+          </a:xfrm>
+          <a:prstGeom prst="rect">
+            <a:avLst/>
+          </a:prstGeom>
+        </p:spPr>
+      </p:pic>
+      <p:sp>
+        <p:nvSpPr>
+          <p:cNvPr id="10" name="TextBox 9"/>
+          <p:cNvSpPr txBox="1"/>
+          <p:nvPr/>
+        </p:nvSpPr>
+        <p:spPr>
+          <a:xfrm>
+            <a:off x="6281928" y="3950207"/>
+            <a:ext cx="5129784" cy="228600"/>
+          </a:xfrm>
+          <a:prstGeom prst="rect">
+            <a:avLst/>
+          </a:prstGeom>
+          <a:noFill/>
+        </p:spPr>
+        <p:txBody>
+          <a:bodyPr wrap="square">
+            <a:spAutoFit/>
+          </a:bodyPr>
+          <a:lstStyle/>
+          <a:p>
+            <a:pPr algn="l"/>
+            <a:r>
+              <a:rPr sz="1050" b="1">
+                <a:solidFill>
+                  <a:srgbClr val="52514E"/>
+                </a:solidFill>
+                <a:latin typeface="Helvetica Neue"/>
+              </a:rPr>
+              <a:t>Resulting verdict: Central line, Severe Delays</a:t>
+            </a:r>
+          </a:p>
+        </p:txBody>
+      </p:sp>
+      <p:sp>
+        <p:nvSpPr>
+          <p:cNvPr id="11" name="TextBox 10"/>
+          <p:cNvSpPr txBox="1"/>
+          <p:nvPr/>
+        </p:nvSpPr>
+        <p:spPr>
+          <a:xfrm>
+            <a:off x="731520" y="4572000"/>
+            <a:ext cx="10698480" cy="1737360"/>
+          </a:xfrm>
+          <a:prstGeom prst="rect">
+            <a:avLst/>
+          </a:prstGeom>
+          <a:noFill/>
+        </p:spPr>
+        <p:txBody>
+          <a:bodyPr wrap="square">
+            <a:spAutoFit/>
+          </a:bodyPr>
+          <a:lstStyle/>
+          <a:p>
             <a:pPr>
               <a:spcAft>
-                <a:spcPts val="1200"/>
+                <a:spcPts val="1000"/>
               </a:spcAft>
             </a:pPr>
             <a:r>
@@ -5184,7 +5171,7 @@
                 </a:solidFill>
                 <a:latin typeface="Helvetica Neue"/>
               </a:rPr>
-              <a:t>Warm subprocess pre-spawning:  </a:t>
+              <a:t>How it stays honest:  </a:t>
             </a:r>
             <a:r>
               <a:rPr sz="1500">
@@ -5193,13 +5180,13 @@
                 </a:solidFill>
                 <a:latin typeface="Helvetica Neue"/>
               </a:rPr>
-              <a:t>one Claude Code subprocess is kept ready ahead of the next request, cutting the ~4s cold-spawn cost off most checks.</a:t>
+              <a:t>the fake status is only injected at the get_line_status / get_line_disruption_detail tools the agent calls — the model still reasons genuinely over it, it just isn't real TfL data.</a:t>
             </a:r>
           </a:p>
           <a:p>
             <a:pPr>
               <a:spcAft>
-                <a:spcPts val="1200"/>
+                <a:spcPts val="1000"/>
               </a:spcAft>
             </a:pPr>
             <a:r>
@@ -5209,7 +5196,7 @@
                 </a:solidFill>
                 <a:latin typeface="Helvetica Neue"/>
               </a:rPr>
-              <a:t>Schema-constrained model output:  </a:t>
+              <a:t>Full-page consistency:  </a:t>
             </a:r>
             <a:r>
               <a:rPr sz="1500">
@@ -5218,107 +5205,7 @@
                 </a:solidFill>
                 <a:latin typeface="Helvetica Neue"/>
               </a:rPr>
-              <a:t>the agent's final answer is forced through a JSON schema, so the server always gets a parseable verdict instead of occasionally-malformed prose.</a:t>
-            </a:r>
-          </a:p>
-          <a:p>
-            <a:pPr>
-              <a:spcAft>
-                <a:spcPts val="1200"/>
-              </a:spcAft>
-            </a:pPr>
-            <a:r>
-              <a:rPr sz="1500" b="1">
-                <a:solidFill>
-                  <a:srgbClr val="2A78D6"/>
-                </a:solidFill>
-                <a:latin typeface="Helvetica Neue"/>
-              </a:rPr>
-              <a:t>Restricted tool surface:  </a:t>
-            </a:r>
-            <a:r>
-              <a:rPr sz="1500">
-                <a:solidFill>
-                  <a:srgbClr val="1A1A1A"/>
-                </a:solidFill>
-                <a:latin typeface="Helvetica Neue"/>
-              </a:rPr>
-              <a:t>the agent gets exactly 4 read-only TfL tools and nothing else — no built-in tools, no filesystem, no ~/.claude settings leaking into a server process.</a:t>
-            </a:r>
-          </a:p>
-          <a:p>
-            <a:pPr>
-              <a:spcAft>
-                <a:spcPts val="1200"/>
-              </a:spcAft>
-            </a:pPr>
-            <a:r>
-              <a:rPr sz="1500" b="1">
-                <a:solidFill>
-                  <a:srgbClr val="2A78D6"/>
-                </a:solidFill>
-                <a:latin typeface="Helvetica Neue"/>
-              </a:rPr>
-              <a:t>Live-vs-usual signature matching:  </a:t>
-            </a:r>
-            <a:r>
-              <a:rPr sz="1500">
-                <a:solidFill>
-                  <a:srgbClr val="1A1A1A"/>
-                </a:solidFill>
-                <a:latin typeface="Helvetica Neue"/>
-              </a:rPr>
-              <a:t>today's live journey is matched to the normal-day baseline by line/mode sequence, not by guesswork, so "your route" is provably the same route.</a:t>
-            </a:r>
-          </a:p>
-          <a:p>
-            <a:pPr>
-              <a:spcAft>
-                <a:spcPts val="1200"/>
-              </a:spcAft>
-            </a:pPr>
-            <a:r>
-              <a:rPr sz="1500" b="1">
-                <a:solidFill>
-                  <a:srgbClr val="2A78D6"/>
-                </a:solidFill>
-                <a:latin typeface="Helvetica Neue"/>
-              </a:rPr>
-              <a:t>Server-side cancel-in-flight:  </a:t>
-            </a:r>
-            <a:r>
-              <a:rPr sz="1500">
-                <a:solidFill>
-                  <a:srgbClr val="1A1A1A"/>
-                </a:solidFill>
-                <a:latin typeface="Helvetica Neue"/>
-              </a:rPr>
-              <a:t>starting a new check interrupts any still-running previous one on the server, not just hiding it in the browser.</a:t>
-            </a:r>
-          </a:p>
-          <a:p>
-            <a:pPr>
-              <a:spcAft>
-                <a:spcPts val="1200"/>
-              </a:spcAft>
-            </a:pPr>
-            <a:r>
-              <a:rPr sz="1500" b="1">
-                <a:solidFill>
-                  <a:srgbClr val="2A78D6"/>
-                </a:solidFill>
-                <a:latin typeface="Helvetica Neue"/>
-              </a:rPr>
-              <a:t>Disruption timestamps:  </a:t>
-            </a:r>
-            <a:r>
-              <a:rPr sz="1500">
-                <a:solidFill>
-                  <a:srgbClr val="1A1A1A"/>
-                </a:solidFill>
-                <a:latin typeface="Helvetica Neue"/>
-              </a:rPr>
-              <a:t>get_line_disruption_detail now carries reportedAt / expectedEnd, so the model can say "unknown" instead of guessing how long an incident will last.</a:t>
+              <a:t>the departure board ticker and the itinerary's per-leg "Disrupted" tag are overridden too, so the whole page agrees with the verdict instead of the text alone claiming a delay nothing else shows.</a:t>
             </a:r>
           </a:p>
         </p:txBody>
@@ -5394,7 +5281,7 @@
         <p:spPr>
           <a:xfrm>
             <a:off x="640080" y="457200"/>
-            <a:ext cx="9144000" cy="640080"/>
+            <a:ext cx="10515600" cy="640080"/>
           </a:xfrm>
           <a:prstGeom prst="rect">
             <a:avLst/>
@@ -5409,13 +5296,13 @@
           <a:p>
             <a:pPr algn="l"/>
             <a:r>
-              <a:rPr sz="3000" b="1">
+              <a:rPr sz="2800" b="1">
                 <a:solidFill>
                   <a:srgbClr val="1A1A1A"/>
                 </a:solidFill>
                 <a:latin typeface="Helvetica Neue"/>
               </a:rPr>
-              <a:t>Tasks tackled &amp; how</a:t>
+              <a:t>Under the hood: changes you can't screenshot</a:t>
             </a:r>
           </a:p>
         </p:txBody>
@@ -5429,7 +5316,7 @@
         <p:spPr>
           <a:xfrm>
             <a:off x="731520" y="1371600"/>
-            <a:ext cx="10515600" cy="4846320"/>
+            <a:ext cx="10698480" cy="5029200"/>
           </a:xfrm>
           <a:prstGeom prst="rect">
             <a:avLst/>
@@ -5444,126 +5331,151 @@
           <a:p>
             <a:pPr>
               <a:spcAft>
-                <a:spcPts val="1400"/>
+                <a:spcPts val="1200"/>
               </a:spcAft>
             </a:pPr>
             <a:r>
-              <a:rPr sz="1700" b="1">
+              <a:rPr sz="1500" b="1">
                 <a:solidFill>
                   <a:srgbClr val="2A78D6"/>
                 </a:solidFill>
                 <a:latin typeface="Helvetica Neue"/>
               </a:rPr>
-              <a:t>Runtime constraint:  </a:t>
-            </a:r>
-            <a:r>
-              <a:rPr sz="1700">
+              <a:t>Warm subprocess pre-spawning:  </a:t>
+            </a:r>
+            <a:r>
+              <a:rPr sz="1500">
                 <a:solidFill>
                   <a:srgbClr val="1A1A1A"/>
                 </a:solidFill>
                 <a:latin typeface="Helvetica Neue"/>
               </a:rPr>
-              <a:t>spec called for Cloudflare Workers, but the Claude Agent SDK spawns a subprocess — no spawning on Workers. Resolved by moving to a long-lived Bun process instead.</a:t>
+              <a:t>one Claude Code subprocess is kept ready ahead of the next request, cutting the ~4s cold-spawn cost off most checks.</a:t>
             </a:r>
           </a:p>
           <a:p>
             <a:pPr>
               <a:spcAft>
-                <a:spcPts val="1400"/>
+                <a:spcPts val="1200"/>
               </a:spcAft>
             </a:pPr>
             <a:r>
-              <a:rPr sz="1700" b="1">
+              <a:rPr sz="1500" b="1">
                 <a:solidFill>
                   <a:srgbClr val="2A78D6"/>
                 </a:solidFill>
                 <a:latin typeface="Helvetica Neue"/>
               </a:rPr>
-              <a:t>Model access:  </a:t>
-            </a:r>
-            <a:r>
-              <a:rPr sz="1700">
+              <a:t>Schema-constrained model output:  </a:t>
+            </a:r>
+            <a:r>
+              <a:rPr sz="1500">
                 <a:solidFill>
                   <a:srgbClr val="1A1A1A"/>
                 </a:solidFill>
                 <a:latin typeface="Helvetica Neue"/>
               </a:rPr>
-              <a:t>verified which Bedrock routes were actually invokable (application inference profiles only, direct model IDs blocked by SCP) before writing the agent code, avoiding a dead end later.</a:t>
+              <a:t>the agent's final answer is forced through a JSON schema, so the server always gets a parseable verdict instead of occasionally-malformed prose.</a:t>
             </a:r>
           </a:p>
           <a:p>
             <a:pPr>
               <a:spcAft>
-                <a:spcPts val="1400"/>
+                <a:spcPts val="1200"/>
               </a:spcAft>
             </a:pPr>
             <a:r>
-              <a:rPr sz="1700" b="1">
+              <a:rPr sz="1500" b="1">
                 <a:solidFill>
                   <a:srgbClr val="2A78D6"/>
                 </a:solidFill>
                 <a:latin typeface="Helvetica Neue"/>
               </a:rPr>
-              <a:t>Live-vs-usual routing logic:  </a:t>
-            </a:r>
-            <a:r>
-              <a:rPr sz="1700">
+              <a:t>Restricted tool surface:  </a:t>
+            </a:r>
+            <a:r>
+              <a:rPr sz="1500">
                 <a:solidFill>
                   <a:srgbClr val="1A1A1A"/>
                 </a:solidFill>
                 <a:latin typeface="Helvetica Neue"/>
               </a:rPr>
-              <a:t>matched today's live journey to the user's usual route by mode/line signature, so "your route" only shows real, live TfL data — not a guess.</a:t>
+              <a:t>the agent gets exactly 4 read-only TfL tools and nothing else — no built-in tools, no filesystem, no ~/.claude settings leaking into a server process.</a:t>
             </a:r>
           </a:p>
           <a:p>
             <a:pPr>
               <a:spcAft>
-                <a:spcPts val="1400"/>
+                <a:spcPts val="1200"/>
               </a:spcAft>
             </a:pPr>
             <a:r>
-              <a:rPr sz="1700" b="1">
+              <a:rPr sz="1500" b="1">
                 <a:solidFill>
                   <a:srgbClr val="2A78D6"/>
                 </a:solidFill>
                 <a:latin typeface="Helvetica Neue"/>
               </a:rPr>
-              <a:t>Iterative UI polish:  </a:t>
-            </a:r>
-            <a:r>
-              <a:rPr sz="1700">
+              <a:t>Live-vs-usual signature matching:  </a:t>
+            </a:r>
+            <a:r>
+              <a:rPr sz="1500">
                 <a:solidFill>
                   <a:srgbClr val="1A1A1A"/>
                 </a:solidFill>
                 <a:latin typeface="Helvetica Neue"/>
               </a:rPr>
-              <a:t>six checkpoints in one session — autocomplete, saved home/work stations, crowding chips, cancel-in-flight requests, dark mode, and a confidence gauge, each shipped and screenshotted as it landed.</a:t>
+              <a:t>today's live journey is matched to the normal-day baseline by line/mode sequence, not by guesswork, so "your route" is provably the same route.</a:t>
             </a:r>
           </a:p>
           <a:p>
             <a:pPr>
               <a:spcAft>
-                <a:spcPts val="1400"/>
+                <a:spcPts val="1200"/>
               </a:spcAft>
             </a:pPr>
             <a:r>
-              <a:rPr sz="1700" b="1">
+              <a:rPr sz="1500" b="1">
                 <a:solidFill>
                   <a:srgbClr val="2A78D6"/>
                 </a:solidFill>
                 <a:latin typeface="Helvetica Neue"/>
               </a:rPr>
-              <a:t>Demo reliability:  </a:t>
-            </a:r>
-            <a:r>
-              <a:rPr sz="1700">
+              <a:t>Server-side cancel-in-flight:  </a:t>
+            </a:r>
+            <a:r>
+              <a:rPr sz="1500">
                 <a:solidFill>
                   <a:srgbClr val="1A1A1A"/>
                 </a:solidFill>
                 <a:latin typeface="Helvetica Neue"/>
               </a:rPr>
-              <a:t>when the judge test showed real disruptions can't be counted on to reproduce, added a demo mode instead of chasing live TfL weather.</a:t>
+              <a:t>starting a new check interrupts any still-running previous one on the server, not just hiding it in the browser.</a:t>
+            </a:r>
+          </a:p>
+          <a:p>
+            <a:pPr>
+              <a:spcAft>
+                <a:spcPts val="1200"/>
+              </a:spcAft>
+            </a:pPr>
+            <a:r>
+              <a:rPr sz="1500" b="1">
+                <a:solidFill>
+                  <a:srgbClr val="2A78D6"/>
+                </a:solidFill>
+                <a:latin typeface="Helvetica Neue"/>
+              </a:rPr>
+              <a:t>Disruption timestamps:  </a:t>
+            </a:r>
+            <a:r>
+              <a:rPr sz="1500">
+                <a:solidFill>
+                  <a:srgbClr val="1A1A1A"/>
+                </a:solidFill>
+                <a:latin typeface="Helvetica Neue"/>
+              </a:rPr>
+              <a:t>get_line_disruption_detail now carries reportedAt / expectedEnd, so the model can say "unknown" instead of guessing how long an incident will last.</a:t>
             </a:r>
           </a:p>
         </p:txBody>
@@ -5577,6 +5489,251 @@
 </file>
 
 <file path=ppt/slides/slide16.xml><?xml version="1.0" encoding="utf-8"?>
+<p:sld xmlns:a="http://schemas.openxmlformats.org/drawingml/2006/main" xmlns:p="http://schemas.openxmlformats.org/presentationml/2006/main" xmlns:r="http://schemas.openxmlformats.org/officeDocument/2006/relationships">
+  <p:cSld>
+    <p:spTree>
+      <p:nvGrpSpPr>
+        <p:cNvPr id="1" name=""/>
+        <p:cNvGrpSpPr/>
+        <p:nvPr/>
+      </p:nvGrpSpPr>
+      <p:grpSpPr/>
+      <p:sp>
+        <p:nvSpPr>
+          <p:cNvPr id="2" name="Rectangle 1"/>
+          <p:cNvSpPr/>
+          <p:nvPr/>
+        </p:nvSpPr>
+        <p:spPr>
+          <a:xfrm>
+            <a:off x="0" y="0"/>
+            <a:ext cx="12191695" cy="6858000"/>
+          </a:xfrm>
+          <a:prstGeom prst="rect">
+            <a:avLst/>
+          </a:prstGeom>
+          <a:solidFill>
+            <a:srgbClr val="FCFCFB"/>
+          </a:solidFill>
+          <a:ln>
+            <a:noFill/>
+          </a:ln>
+          <a:effectLst/>
+        </p:spPr>
+        <p:style>
+          <a:lnRef idx="1">
+            <a:schemeClr val="accent1"/>
+          </a:lnRef>
+          <a:fillRef idx="3">
+            <a:schemeClr val="accent1"/>
+          </a:fillRef>
+          <a:effectRef idx="2">
+            <a:schemeClr val="accent1"/>
+          </a:effectRef>
+          <a:fontRef idx="minor">
+            <a:schemeClr val="lt1"/>
+          </a:fontRef>
+        </p:style>
+        <p:txBody>
+          <a:bodyPr rtlCol="0" anchor="ctr"/>
+          <a:lstStyle/>
+          <a:p>
+            <a:pPr algn="ctr"/>
+          </a:p>
+        </p:txBody>
+      </p:sp>
+      <p:sp>
+        <p:nvSpPr>
+          <p:cNvPr id="3" name="TextBox 2"/>
+          <p:cNvSpPr txBox="1"/>
+          <p:nvPr/>
+        </p:nvSpPr>
+        <p:spPr>
+          <a:xfrm>
+            <a:off x="640080" y="457200"/>
+            <a:ext cx="9144000" cy="640080"/>
+          </a:xfrm>
+          <a:prstGeom prst="rect">
+            <a:avLst/>
+          </a:prstGeom>
+          <a:noFill/>
+        </p:spPr>
+        <p:txBody>
+          <a:bodyPr wrap="square">
+            <a:spAutoFit/>
+          </a:bodyPr>
+          <a:lstStyle/>
+          <a:p>
+            <a:pPr algn="l"/>
+            <a:r>
+              <a:rPr sz="3000" b="1">
+                <a:solidFill>
+                  <a:srgbClr val="1A1A1A"/>
+                </a:solidFill>
+                <a:latin typeface="Helvetica Neue"/>
+              </a:rPr>
+              <a:t>Tasks tackled &amp; how</a:t>
+            </a:r>
+          </a:p>
+        </p:txBody>
+      </p:sp>
+      <p:sp>
+        <p:nvSpPr>
+          <p:cNvPr id="4" name="TextBox 3"/>
+          <p:cNvSpPr txBox="1"/>
+          <p:nvPr/>
+        </p:nvSpPr>
+        <p:spPr>
+          <a:xfrm>
+            <a:off x="731520" y="1371600"/>
+            <a:ext cx="10515600" cy="4846320"/>
+          </a:xfrm>
+          <a:prstGeom prst="rect">
+            <a:avLst/>
+          </a:prstGeom>
+          <a:noFill/>
+        </p:spPr>
+        <p:txBody>
+          <a:bodyPr wrap="square">
+            <a:spAutoFit/>
+          </a:bodyPr>
+          <a:lstStyle/>
+          <a:p>
+            <a:pPr>
+              <a:spcAft>
+                <a:spcPts val="1400"/>
+              </a:spcAft>
+            </a:pPr>
+            <a:r>
+              <a:rPr sz="1700" b="1">
+                <a:solidFill>
+                  <a:srgbClr val="2A78D6"/>
+                </a:solidFill>
+                <a:latin typeface="Helvetica Neue"/>
+              </a:rPr>
+              <a:t>Runtime constraint:  </a:t>
+            </a:r>
+            <a:r>
+              <a:rPr sz="1700">
+                <a:solidFill>
+                  <a:srgbClr val="1A1A1A"/>
+                </a:solidFill>
+                <a:latin typeface="Helvetica Neue"/>
+              </a:rPr>
+              <a:t>spec called for Cloudflare Workers, but the Claude Agent SDK spawns a subprocess — no spawning on Workers. Resolved by moving to a long-lived Bun process instead.</a:t>
+            </a:r>
+          </a:p>
+          <a:p>
+            <a:pPr>
+              <a:spcAft>
+                <a:spcPts val="1400"/>
+              </a:spcAft>
+            </a:pPr>
+            <a:r>
+              <a:rPr sz="1700" b="1">
+                <a:solidFill>
+                  <a:srgbClr val="2A78D6"/>
+                </a:solidFill>
+                <a:latin typeface="Helvetica Neue"/>
+              </a:rPr>
+              <a:t>Model access:  </a:t>
+            </a:r>
+            <a:r>
+              <a:rPr sz="1700">
+                <a:solidFill>
+                  <a:srgbClr val="1A1A1A"/>
+                </a:solidFill>
+                <a:latin typeface="Helvetica Neue"/>
+              </a:rPr>
+              <a:t>verified which Bedrock routes were actually invokable (application inference profiles only, direct model IDs blocked by SCP) before writing the agent code, avoiding a dead end later.</a:t>
+            </a:r>
+          </a:p>
+          <a:p>
+            <a:pPr>
+              <a:spcAft>
+                <a:spcPts val="1400"/>
+              </a:spcAft>
+            </a:pPr>
+            <a:r>
+              <a:rPr sz="1700" b="1">
+                <a:solidFill>
+                  <a:srgbClr val="2A78D6"/>
+                </a:solidFill>
+                <a:latin typeface="Helvetica Neue"/>
+              </a:rPr>
+              <a:t>Live-vs-usual routing logic:  </a:t>
+            </a:r>
+            <a:r>
+              <a:rPr sz="1700">
+                <a:solidFill>
+                  <a:srgbClr val="1A1A1A"/>
+                </a:solidFill>
+                <a:latin typeface="Helvetica Neue"/>
+              </a:rPr>
+              <a:t>matched today's live journey to the user's usual route by mode/line signature, so "your route" only shows real, live TfL data — not a guess.</a:t>
+            </a:r>
+          </a:p>
+          <a:p>
+            <a:pPr>
+              <a:spcAft>
+                <a:spcPts val="1400"/>
+              </a:spcAft>
+            </a:pPr>
+            <a:r>
+              <a:rPr sz="1700" b="1">
+                <a:solidFill>
+                  <a:srgbClr val="2A78D6"/>
+                </a:solidFill>
+                <a:latin typeface="Helvetica Neue"/>
+              </a:rPr>
+              <a:t>Iterative UI polish:  </a:t>
+            </a:r>
+            <a:r>
+              <a:rPr sz="1700">
+                <a:solidFill>
+                  <a:srgbClr val="1A1A1A"/>
+                </a:solidFill>
+                <a:latin typeface="Helvetica Neue"/>
+              </a:rPr>
+              <a:t>six checkpoints in one session — autocomplete, saved home/work stations, crowding chips, cancel-in-flight requests, dark mode, and a confidence gauge, each shipped and screenshotted as it landed.</a:t>
+            </a:r>
+          </a:p>
+          <a:p>
+            <a:pPr>
+              <a:spcAft>
+                <a:spcPts val="1400"/>
+              </a:spcAft>
+            </a:pPr>
+            <a:r>
+              <a:rPr sz="1700" b="1">
+                <a:solidFill>
+                  <a:srgbClr val="2A78D6"/>
+                </a:solidFill>
+                <a:latin typeface="Helvetica Neue"/>
+              </a:rPr>
+              <a:t>Demo reliability:  </a:t>
+            </a:r>
+            <a:r>
+              <a:rPr sz="1700">
+                <a:solidFill>
+                  <a:srgbClr val="1A1A1A"/>
+                </a:solidFill>
+                <a:latin typeface="Helvetica Neue"/>
+              </a:rPr>
+              <a:t>when the judge test showed real disruptions can't be counted on to reproduce, added a demo mode instead of chasing live TfL weather.</a:t>
+            </a:r>
+          </a:p>
+        </p:txBody>
+      </p:sp>
+    </p:spTree>
+  </p:cSld>
+  <p:clrMapOvr>
+    <a:masterClrMapping/>
+  </p:clrMapOvr>
+</p:sld>
+</file>
+
+<file path=ppt/slides/slide17.xml><?xml version="1.0" encoding="utf-8"?>
 <p:sld xmlns:a="http://schemas.openxmlformats.org/drawingml/2006/main" xmlns:p="http://schemas.openxmlformats.org/presentationml/2006/main" xmlns:r="http://schemas.openxmlformats.org/officeDocument/2006/relationships">
   <p:cSld>
     <p:spTree>

</xml_diff>